<commit_message>
Update EDI ENERGIE Soutenance.pptx
</commit_message>
<xml_diff>
--- a/EDI ENERGIE Soutenance.pptx
+++ b/EDI ENERGIE Soutenance.pptx
@@ -3911,7 +3911,7 @@
               <a:t>l'utilisateur, </a:t>
             </a:r>
             <a:r>
-              <a:rPr lang="en-US" sz="1150" dirty="0" err="1" smtClean="0">
+              <a:rPr lang="en-US" sz="1150" dirty="0" smtClean="0">
                 <a:solidFill>
                   <a:srgbClr val="1A1F2E"/>
                 </a:solidFill>
@@ -3919,7 +3919,7 @@
                 <a:ea typeface="Calibri" pitchFamily="34" charset="-122"/>
                 <a:cs typeface="Calibri" pitchFamily="34" charset="-120"/>
               </a:rPr>
-              <a:t>fonctionnalités,limites,règles</a:t>
+              <a:t>fonctionnalités, limites, règles </a:t>
             </a:r>
             <a:r>
               <a:rPr lang="en-US" sz="1150" dirty="0" smtClean="0">
@@ -3930,7 +3930,7 @@
                 <a:ea typeface="Calibri" pitchFamily="34" charset="-122"/>
                 <a:cs typeface="Calibri" pitchFamily="34" charset="-120"/>
               </a:rPr>
-              <a:t> métier</a:t>
+              <a:t>métier</a:t>
             </a:r>
             <a:endParaRPr lang="en-US" sz="1150" dirty="0"/>
           </a:p>
@@ -17527,20 +17527,10 @@
                 <a:ea typeface="Calibri" pitchFamily="34" charset="-122"/>
                 <a:cs typeface="Calibri" pitchFamily="34" charset="-120"/>
               </a:rPr>
-              <a:t>Id et classe Client</a:t>
-            </a:r>
-            <a:endParaRPr lang="en-US" sz="1150" dirty="0"/>
-          </a:p>
-          <a:p>
-            <a:pPr marL="342900" indent="-342900">
-              <a:spcAft>
-                <a:spcPts val="700"/>
-              </a:spcAft>
-              <a:buSzPct val="100000"/>
-              <a:buChar char="•"/>
-            </a:pPr>
-            <a:r>
-              <a:rPr lang="en-US" sz="1150" dirty="0">
+              <a:t>Id et classe </a:t>
+            </a:r>
+            <a:r>
+              <a:rPr lang="en-US" sz="1150" dirty="0" smtClean="0">
                 <a:solidFill>
                   <a:srgbClr val="1A1F2E"/>
                 </a:solidFill>
@@ -17548,19 +17538,16 @@
                 <a:ea typeface="Calibri" pitchFamily="34" charset="-122"/>
                 <a:cs typeface="Calibri" pitchFamily="34" charset="-120"/>
               </a:rPr>
-              <a:t>Classes Compteur / </a:t>
-            </a:r>
-            <a:r>
-              <a:rPr lang="en-US" sz="1150" dirty="0" smtClean="0">
-                <a:solidFill>
-                  <a:srgbClr val="1A1F2E"/>
-                </a:solidFill>
-                <a:latin typeface="Calibri" pitchFamily="34" charset="0"/>
-                <a:ea typeface="Calibri" pitchFamily="34" charset="-122"/>
-                <a:cs typeface="Calibri" pitchFamily="34" charset="-120"/>
-              </a:rPr>
-              <a:t>Facture</a:t>
-            </a:r>
+              <a:t>Client</a:t>
+            </a:r>
+            <a:endParaRPr lang="en-US" sz="1150" dirty="0" smtClean="0">
+              <a:solidFill>
+                <a:srgbClr val="1A1F2E"/>
+              </a:solidFill>
+              <a:latin typeface="Calibri" pitchFamily="34" charset="0"/>
+              <a:ea typeface="Calibri" pitchFamily="34" charset="-122"/>
+              <a:cs typeface="Calibri" pitchFamily="34" charset="-120"/>
+            </a:endParaRPr>
           </a:p>
           <a:p>
             <a:pPr marL="342900" indent="-342900">
@@ -17932,7 +17919,18 @@
                 <a:ea typeface="Calibri" pitchFamily="34" charset="-122"/>
                 <a:cs typeface="Calibri" pitchFamily="34" charset="-120"/>
               </a:rPr>
-              <a:t>ConnexionGU</a:t>
+              <a:t>Main</a:t>
+            </a:r>
+            <a:r>
+              <a:rPr lang="en-US" sz="1150" dirty="0" smtClean="0">
+                <a:solidFill>
+                  <a:srgbClr val="1A1F2E"/>
+                </a:solidFill>
+                <a:latin typeface="Calibri" pitchFamily="34" charset="0"/>
+                <a:ea typeface="Calibri" pitchFamily="34" charset="-122"/>
+                <a:cs typeface="Calibri" pitchFamily="34" charset="-120"/>
+              </a:rPr>
+              <a:t>GU</a:t>
             </a:r>
             <a:endParaRPr lang="en-US" sz="1150" dirty="0"/>
           </a:p>

</xml_diff>